<commit_message>
Polish deck per final QA: risk-label padding, card balance
Independent visual-QA pass flagged one real defect and two nits:
- Slide 5: the right-aligned risk labels (High/Elevated/Low) touched the inner
  row-card edge; add right padding so they no longer kiss the corner.
- Slide 2: tighten the recommendation card height to its content.
- Slide 10: reduce testimonial card height / lift attributions for balance.

Co-Authored-By: Claude Opus 4.8 <noreply@anthropic.com>
Claude-Session: https://claude.ai/code/session_01S9pmxQzudKvQSiqYoiCxEh
</commit_message>
<xml_diff>
--- a/teton-product-recommendation-template.pptx
+++ b/teton-product-recommendation-template.pptx
@@ -2215,7 +2215,7 @@
         <p:spPr>
           <a:xfrm>
             <a:off x="777240" y="2103120"/>
-            <a:ext cx="3401568" cy="3840480"/>
+            <a:ext cx="3401568" cy="3520440"/>
           </a:xfrm>
           <a:prstGeom prst="roundRect">
             <a:avLst>
@@ -2314,8 +2314,8 @@
         </p:nvSpPr>
         <p:spPr>
           <a:xfrm>
-            <a:off x="1097280" y="3291840"/>
-            <a:ext cx="2761488" cy="1828800"/>
+            <a:off x="1097280" y="3246120"/>
+            <a:ext cx="2761488" cy="1554480"/>
           </a:xfrm>
           <a:prstGeom prst="rect">
             <a:avLst/>
@@ -2356,7 +2356,7 @@
         </p:nvSpPr>
         <p:spPr>
           <a:xfrm>
-            <a:off x="1097280" y="5303520"/>
+            <a:off x="1097280" y="5001768"/>
             <a:ext cx="2761488" cy="365760"/>
           </a:xfrm>
           <a:prstGeom prst="rect">
@@ -2410,7 +2410,7 @@
         <p:spPr>
           <a:xfrm>
             <a:off x="4389120" y="2103120"/>
-            <a:ext cx="3401568" cy="3840480"/>
+            <a:ext cx="3401568" cy="3520440"/>
           </a:xfrm>
           <a:prstGeom prst="roundRect">
             <a:avLst>
@@ -2509,8 +2509,8 @@
         </p:nvSpPr>
         <p:spPr>
           <a:xfrm>
-            <a:off x="4709160" y="3291840"/>
-            <a:ext cx="2761488" cy="1828800"/>
+            <a:off x="4709160" y="3246120"/>
+            <a:ext cx="2761488" cy="1554480"/>
           </a:xfrm>
           <a:prstGeom prst="rect">
             <a:avLst/>
@@ -2551,7 +2551,7 @@
         </p:nvSpPr>
         <p:spPr>
           <a:xfrm>
-            <a:off x="4709160" y="5303520"/>
+            <a:off x="4709160" y="5001768"/>
             <a:ext cx="2761488" cy="365760"/>
           </a:xfrm>
           <a:prstGeom prst="rect">
@@ -2605,7 +2605,7 @@
         <p:spPr>
           <a:xfrm>
             <a:off x="8001000" y="2103120"/>
-            <a:ext cx="3401568" cy="3840480"/>
+            <a:ext cx="3401568" cy="3520440"/>
           </a:xfrm>
           <a:prstGeom prst="roundRect">
             <a:avLst>
@@ -2704,8 +2704,8 @@
         </p:nvSpPr>
         <p:spPr>
           <a:xfrm>
-            <a:off x="8321040" y="3291840"/>
-            <a:ext cx="2761488" cy="1828800"/>
+            <a:off x="8321040" y="3246120"/>
+            <a:ext cx="2761488" cy="1554480"/>
           </a:xfrm>
           <a:prstGeom prst="rect">
             <a:avLst/>
@@ -2746,7 +2746,7 @@
         </p:nvSpPr>
         <p:spPr>
           <a:xfrm>
-            <a:off x="8321040" y="5303520"/>
+            <a:off x="8321040" y="5001768"/>
             <a:ext cx="2761488" cy="365760"/>
           </a:xfrm>
           <a:prstGeom prst="rect">
@@ -4219,11 +4219,11 @@
         <p:spPr>
           <a:xfrm>
             <a:off x="777240" y="2011680"/>
-            <a:ext cx="6720840" cy="3977640"/>
+            <a:ext cx="6720840" cy="3703320"/>
           </a:xfrm>
           <a:prstGeom prst="roundRect">
             <a:avLst>
-              <a:gd name="adj" fmla="val 3218"/>
+              <a:gd name="adj" fmla="val 3457"/>
             </a:avLst>
           </a:prstGeom>
           <a:solidFill>
@@ -6231,7 +6231,7 @@
         </p:nvSpPr>
         <p:spPr>
           <a:xfrm>
-            <a:off x="7223760" y="3255264"/>
+            <a:off x="7287768" y="3255264"/>
             <a:ext cx="182880" cy="182880"/>
           </a:xfrm>
           <a:prstGeom prst="ellipse">
@@ -6251,8 +6251,8 @@
         </p:nvSpPr>
         <p:spPr>
           <a:xfrm>
-            <a:off x="7498080" y="3017520"/>
-            <a:ext cx="2679192" cy="658368"/>
+            <a:off x="7589520" y="3017520"/>
+            <a:ext cx="2011680" cy="658368"/>
           </a:xfrm>
           <a:prstGeom prst="rect">
             <a:avLst/>
@@ -6290,8 +6290,8 @@
         </p:nvSpPr>
         <p:spPr>
           <a:xfrm>
-            <a:off x="9902952" y="3017520"/>
-            <a:ext cx="1188720" cy="658368"/>
+            <a:off x="9765792" y="3017520"/>
+            <a:ext cx="1051560" cy="658368"/>
           </a:xfrm>
           <a:prstGeom prst="rect">
             <a:avLst/>
@@ -6351,7 +6351,7 @@
         </p:nvSpPr>
         <p:spPr>
           <a:xfrm>
-            <a:off x="7223760" y="4078224"/>
+            <a:off x="7287768" y="4078224"/>
             <a:ext cx="182880" cy="182880"/>
           </a:xfrm>
           <a:prstGeom prst="ellipse">
@@ -6371,8 +6371,8 @@
         </p:nvSpPr>
         <p:spPr>
           <a:xfrm>
-            <a:off x="7498080" y="3840480"/>
-            <a:ext cx="2679192" cy="658368"/>
+            <a:off x="7589520" y="3840480"/>
+            <a:ext cx="2011680" cy="658368"/>
           </a:xfrm>
           <a:prstGeom prst="rect">
             <a:avLst/>
@@ -6410,8 +6410,8 @@
         </p:nvSpPr>
         <p:spPr>
           <a:xfrm>
-            <a:off x="9902952" y="3840480"/>
-            <a:ext cx="1188720" cy="658368"/>
+            <a:off x="9765792" y="3840480"/>
+            <a:ext cx="1051560" cy="658368"/>
           </a:xfrm>
           <a:prstGeom prst="rect">
             <a:avLst/>
@@ -6471,7 +6471,7 @@
         </p:nvSpPr>
         <p:spPr>
           <a:xfrm>
-            <a:off x="7223760" y="4901184"/>
+            <a:off x="7287768" y="4901184"/>
             <a:ext cx="182880" cy="182880"/>
           </a:xfrm>
           <a:prstGeom prst="ellipse">
@@ -6491,8 +6491,8 @@
         </p:nvSpPr>
         <p:spPr>
           <a:xfrm>
-            <a:off x="7498080" y="4663440"/>
-            <a:ext cx="2679192" cy="658368"/>
+            <a:off x="7589520" y="4663440"/>
+            <a:ext cx="2011680" cy="658368"/>
           </a:xfrm>
           <a:prstGeom prst="rect">
             <a:avLst/>
@@ -6530,8 +6530,8 @@
         </p:nvSpPr>
         <p:spPr>
           <a:xfrm>
-            <a:off x="9902952" y="4663440"/>
-            <a:ext cx="1188720" cy="658368"/>
+            <a:off x="9765792" y="4663440"/>
+            <a:ext cx="1051560" cy="658368"/>
           </a:xfrm>
           <a:prstGeom prst="rect">
             <a:avLst/>

</xml_diff>